<commit_message>
feat: establish text region and layout baseline
</commit_message>
<xml_diff>
--- a/assets/结构图/分支决策-001/example.pptx
+++ b/assets/结构图/分支决策-001/example.pptx
@@ -2,13 +2,13 @@
 <file path=ppt/presentation.xml><?xml version="1.0" encoding="utf-8"?>
 <p:presentation xmlns:p="http://schemas.openxmlformats.org/presentationml/2006/main">
   <p:sldMasterIdLst>
-    <p:sldMasterId xmlns:r="http://schemas.openxmlformats.org/officeDocument/2006/relationships" id="2147483648" r:id="R52923c2cb0ce4590"/>
+    <p:sldMasterId xmlns:r="http://schemas.openxmlformats.org/officeDocument/2006/relationships" id="2147483648" r:id="Rad669b7c1aa047ed"/>
   </p:sldMasterIdLst>
   <p:notesMasterIdLst>
-    <p:notesMasterId xmlns:r="http://schemas.openxmlformats.org/officeDocument/2006/relationships" r:id="R743c5a0f470b4aa1"/>
+    <p:notesMasterId xmlns:r="http://schemas.openxmlformats.org/officeDocument/2006/relationships" r:id="R9130c2cccb234e1f"/>
   </p:notesMasterIdLst>
   <p:sldIdLst>
-    <p:sldId xmlns:r="http://schemas.openxmlformats.org/officeDocument/2006/relationships" id="256" r:id="R501ef2305e824493"/>
+    <p:sldId xmlns:r="http://schemas.openxmlformats.org/officeDocument/2006/relationships" id="256" r:id="R22e85525ff9348e2"/>
   </p:sldIdLst>
   <p:sldSz cx="12192000" cy="6858000"/>
   <p:notesSz cx="6858000" cy="9144000"/>
@@ -360,18 +360,36 @@
         </a:effectStyle>
         <a:effectStyle>
           <a:effectLst>
+            <a:outerShdw blurRad="266700" dist="114300" dir="5400000">
+              <a:srgbClr val="2F5EA8">
+                <a:alpha val="22000"/>
+              </a:srgbClr>
+            </a:outerShdw>
+          </a:effectLst>
+        </a:effectStyle>
+        <a:effectStyle>
+          <a:effectLst>
+            <a:outerShdw blurRad="152400" dist="66675" dir="5400000">
+              <a:srgbClr val="2F5EA8">
+                <a:alpha val="9000"/>
+              </a:srgbClr>
+            </a:outerShdw>
+          </a:effectLst>
+        </a:effectStyle>
+        <a:effectStyle>
+          <a:effectLst>
+            <a:outerShdw blurRad="152400" dist="66675" dir="5400000">
+              <a:srgbClr val="2F5EA8">
+                <a:alpha val="10000"/>
+              </a:srgbClr>
+            </a:outerShdw>
+          </a:effectLst>
+        </a:effectStyle>
+        <a:effectStyle>
+          <a:effectLst>
             <a:outerShdw blurRad="171450" dist="76200" dir="5400000">
               <a:srgbClr val="2F5EA8">
                 <a:alpha val="16000"/>
-              </a:srgbClr>
-            </a:outerShdw>
-          </a:effectLst>
-        </a:effectStyle>
-        <a:effectStyle>
-          <a:effectLst>
-            <a:outerShdw blurRad="152400" dist="66675" dir="5400000">
-              <a:srgbClr val="2F5EA8">
-                <a:alpha val="10000"/>
               </a:srgbClr>
             </a:outerShdw>
           </a:effectLst>
@@ -542,7 +560,7 @@
   </p:cSld>
   <p:clrMap bg1="lt1" tx1="dk1" bg2="lt2" tx2="dk2" accent1="accent1" accent2="accent2" accent3="accent3" accent4="accent4" accent5="accent5" accent6="accent6" hlink="hlink" folHlink="folHlink"/>
   <p:sldLayoutIdLst>
-    <p:sldLayoutId xmlns:r="http://schemas.openxmlformats.org/officeDocument/2006/relationships" id="2147483649" r:id="Rf2bebbb90cb849ee"/>
+    <p:sldLayoutId xmlns:r="http://schemas.openxmlformats.org/officeDocument/2006/relationships" id="2147483649" r:id="Rdf67fe123bfa4aea"/>
   </p:sldLayoutIdLst>
   <p:txStyles>
     <p:titleStyle>
@@ -1027,18 +1045,36 @@
         </a:effectStyle>
         <a:effectStyle>
           <a:effectLst>
+            <a:outerShdw blurRad="266700" dist="114300" dir="5400000">
+              <a:srgbClr val="2F5EA8">
+                <a:alpha val="22000"/>
+              </a:srgbClr>
+            </a:outerShdw>
+          </a:effectLst>
+        </a:effectStyle>
+        <a:effectStyle>
+          <a:effectLst>
+            <a:outerShdw blurRad="152400" dist="66675" dir="5400000">
+              <a:srgbClr val="2F5EA8">
+                <a:alpha val="9000"/>
+              </a:srgbClr>
+            </a:outerShdw>
+          </a:effectLst>
+        </a:effectStyle>
+        <a:effectStyle>
+          <a:effectLst>
+            <a:outerShdw blurRad="152400" dist="66675" dir="5400000">
+              <a:srgbClr val="2F5EA8">
+                <a:alpha val="10000"/>
+              </a:srgbClr>
+            </a:outerShdw>
+          </a:effectLst>
+        </a:effectStyle>
+        <a:effectStyle>
+          <a:effectLst>
             <a:outerShdw blurRad="171450" dist="76200" dir="5400000">
               <a:srgbClr val="2F5EA8">
                 <a:alpha val="16000"/>
-              </a:srgbClr>
-            </a:outerShdw>
-          </a:effectLst>
-        </a:effectStyle>
-        <a:effectStyle>
-          <a:effectLst>
-            <a:outerShdw blurRad="152400" dist="66675" dir="5400000">
-              <a:srgbClr val="2F5EA8">
-                <a:alpha val="10000"/>
               </a:srgbClr>
             </a:outerShdw>
           </a:effectLst>
@@ -1129,7 +1165,7 @@
           <p:cNvPr id="36" name="context-decision-link">
             <a:extLst xmlns:a="http://schemas.openxmlformats.org/drawingml/2006/main">
               <a:ext uri="{FF2B5EF4-FFF2-40B4-BE49-F238E27FC236}">
-                <a16:creationId xmlns:a16="http://schemas.microsoft.com/office/drawing/2014/main" id="{C76BDB87-707B-49E4-9149-200BE657D564}"/>
+                <a16:creationId xmlns:a16="http://schemas.microsoft.com/office/drawing/2014/main" id="{2E168509-E92C-4D15-A164-4841AB6710D3}"/>
               </a:ext>
             </a:extLst>
           </p:cNvPr>
@@ -1160,7 +1196,7 @@
           <p:cNvPr id="2" name="decision-bus-link">
             <a:extLst xmlns:a="http://schemas.openxmlformats.org/drawingml/2006/main">
               <a:ext uri="{FF2B5EF4-FFF2-40B4-BE49-F238E27FC236}">
-                <a16:creationId xmlns:a16="http://schemas.microsoft.com/office/drawing/2014/main" id="{2F1A8183-7DBB-442D-8E73-B8D82AFE2EA7}"/>
+                <a16:creationId xmlns:a16="http://schemas.microsoft.com/office/drawing/2014/main" id="{3356E171-87F4-4391-B4FB-45CF1B5C60D3}"/>
               </a:ext>
             </a:extLst>
           </p:cNvPr>
@@ -1191,7 +1227,7 @@
           <p:cNvPr id="3" name="decision-branch-bus">
             <a:extLst xmlns:a="http://schemas.openxmlformats.org/drawingml/2006/main">
               <a:ext uri="{FF2B5EF4-FFF2-40B4-BE49-F238E27FC236}">
-                <a16:creationId xmlns:a16="http://schemas.microsoft.com/office/drawing/2014/main" id="{8F530373-3602-4A72-8164-1A7BCA3F577E}"/>
+                <a16:creationId xmlns:a16="http://schemas.microsoft.com/office/drawing/2014/main" id="{8AEF667C-96A3-42C6-881B-2BAC594A53FF}"/>
               </a:ext>
             </a:extLst>
           </p:cNvPr>
@@ -1222,7 +1258,7 @@
           <p:cNvPr id="4" name="decision-branch-link-0">
             <a:extLst xmlns:a="http://schemas.openxmlformats.org/drawingml/2006/main">
               <a:ext uri="{FF2B5EF4-FFF2-40B4-BE49-F238E27FC236}">
-                <a16:creationId xmlns:a16="http://schemas.microsoft.com/office/drawing/2014/main" id="{FE4DD532-699F-4937-8F6C-659680928AAF}"/>
+                <a16:creationId xmlns:a16="http://schemas.microsoft.com/office/drawing/2014/main" id="{9B91460D-31F1-4969-8484-A154A28B5652}"/>
               </a:ext>
             </a:extLst>
           </p:cNvPr>
@@ -1253,7 +1289,7 @@
           <p:cNvPr id="5" name="decision-branch-anchor-0">
             <a:extLst xmlns:a="http://schemas.openxmlformats.org/drawingml/2006/main">
               <a:ext uri="{FF2B5EF4-FFF2-40B4-BE49-F238E27FC236}">
-                <a16:creationId xmlns:a16="http://schemas.microsoft.com/office/drawing/2014/main" id="{C8CF0F56-0C3C-4D44-A7E8-3E59BE6BE6C1}"/>
+                <a16:creationId xmlns:a16="http://schemas.microsoft.com/office/drawing/2014/main" id="{61F7E6EF-28F2-4000-A958-609D3BB1EECE}"/>
               </a:ext>
             </a:extLst>
           </p:cNvPr>
@@ -1286,7 +1322,7 @@
           <p:cNvPr id="6" name="branch-outcome-link-0">
             <a:extLst xmlns:a="http://schemas.openxmlformats.org/drawingml/2006/main">
               <a:ext uri="{FF2B5EF4-FFF2-40B4-BE49-F238E27FC236}">
-                <a16:creationId xmlns:a16="http://schemas.microsoft.com/office/drawing/2014/main" id="{7559BA47-6A0A-4A68-B513-55F38F330935}"/>
+                <a16:creationId xmlns:a16="http://schemas.microsoft.com/office/drawing/2014/main" id="{77ADF6DC-9CB4-40B8-816A-925DBEADFA7D}"/>
               </a:ext>
             </a:extLst>
           </p:cNvPr>
@@ -1317,7 +1353,7 @@
           <p:cNvPr id="7" name="decision-branch-link-1">
             <a:extLst xmlns:a="http://schemas.openxmlformats.org/drawingml/2006/main">
               <a:ext uri="{FF2B5EF4-FFF2-40B4-BE49-F238E27FC236}">
-                <a16:creationId xmlns:a16="http://schemas.microsoft.com/office/drawing/2014/main" id="{7F72A9A9-4342-467F-97CE-4BEF489AD934}"/>
+                <a16:creationId xmlns:a16="http://schemas.microsoft.com/office/drawing/2014/main" id="{BA0AAC94-93F8-4028-9B02-1A979E5741A4}"/>
               </a:ext>
             </a:extLst>
           </p:cNvPr>
@@ -1348,7 +1384,7 @@
           <p:cNvPr id="8" name="decision-branch-anchor-1">
             <a:extLst xmlns:a="http://schemas.openxmlformats.org/drawingml/2006/main">
               <a:ext uri="{FF2B5EF4-FFF2-40B4-BE49-F238E27FC236}">
-                <a16:creationId xmlns:a16="http://schemas.microsoft.com/office/drawing/2014/main" id="{066CD674-48CB-44F0-9BE3-1D64ACA0290C}"/>
+                <a16:creationId xmlns:a16="http://schemas.microsoft.com/office/drawing/2014/main" id="{655A6443-CC2A-4656-8C18-12D65AF8E001}"/>
               </a:ext>
             </a:extLst>
           </p:cNvPr>
@@ -1381,7 +1417,7 @@
           <p:cNvPr id="9" name="branch-outcome-link-1">
             <a:extLst xmlns:a="http://schemas.openxmlformats.org/drawingml/2006/main">
               <a:ext uri="{FF2B5EF4-FFF2-40B4-BE49-F238E27FC236}">
-                <a16:creationId xmlns:a16="http://schemas.microsoft.com/office/drawing/2014/main" id="{59494C6C-DB6E-4891-B1B7-BA721DF5EEF4}"/>
+                <a16:creationId xmlns:a16="http://schemas.microsoft.com/office/drawing/2014/main" id="{DF0382DD-1A76-4FA2-9E70-CF1A26DC5212}"/>
               </a:ext>
             </a:extLst>
           </p:cNvPr>
@@ -1412,7 +1448,7 @@
           <p:cNvPr id="10" name="decision-branch-link-2">
             <a:extLst xmlns:a="http://schemas.openxmlformats.org/drawingml/2006/main">
               <a:ext uri="{FF2B5EF4-FFF2-40B4-BE49-F238E27FC236}">
-                <a16:creationId xmlns:a16="http://schemas.microsoft.com/office/drawing/2014/main" id="{44D2E7B0-6E72-420E-8156-08CD70ACADE9}"/>
+                <a16:creationId xmlns:a16="http://schemas.microsoft.com/office/drawing/2014/main" id="{BD20F80E-A18C-4045-934C-67913FACC021}"/>
               </a:ext>
             </a:extLst>
           </p:cNvPr>
@@ -1443,7 +1479,7 @@
           <p:cNvPr id="11" name="decision-branch-anchor-2">
             <a:extLst xmlns:a="http://schemas.openxmlformats.org/drawingml/2006/main">
               <a:ext uri="{FF2B5EF4-FFF2-40B4-BE49-F238E27FC236}">
-                <a16:creationId xmlns:a16="http://schemas.microsoft.com/office/drawing/2014/main" id="{1E21A6AF-ADE6-4750-889D-E9F65212487D}"/>
+                <a16:creationId xmlns:a16="http://schemas.microsoft.com/office/drawing/2014/main" id="{2AEC6C74-78B2-4EFB-8933-65D88A6E32B4}"/>
               </a:ext>
             </a:extLst>
           </p:cNvPr>
@@ -1476,7 +1512,7 @@
           <p:cNvPr id="12" name="branch-outcome-link-2">
             <a:extLst xmlns:a="http://schemas.openxmlformats.org/drawingml/2006/main">
               <a:ext uri="{FF2B5EF4-FFF2-40B4-BE49-F238E27FC236}">
-                <a16:creationId xmlns:a16="http://schemas.microsoft.com/office/drawing/2014/main" id="{A1A85424-9F31-4339-8CE4-089F3B49E957}"/>
+                <a16:creationId xmlns:a16="http://schemas.microsoft.com/office/drawing/2014/main" id="{E04DD82F-9AB1-40EE-B86E-AE1DD1CE477C}"/>
               </a:ext>
             </a:extLst>
           </p:cNvPr>
@@ -1507,7 +1543,7 @@
           <p:cNvPr id="13" name="decision-context-underlay">
             <a:extLst xmlns:a="http://schemas.openxmlformats.org/drawingml/2006/main">
               <a:ext uri="{FF2B5EF4-FFF2-40B4-BE49-F238E27FC236}">
-                <a16:creationId xmlns:a16="http://schemas.microsoft.com/office/drawing/2014/main" id="{5132F83B-5B3B-4AAC-8867-BA269556F0B9}"/>
+                <a16:creationId xmlns:a16="http://schemas.microsoft.com/office/drawing/2014/main" id="{0FE04029-AA3E-48C8-8A67-268F90B0B890}"/>
               </a:ext>
             </a:extLst>
           </p:cNvPr>
@@ -1540,7 +1576,7 @@
           <p:cNvPr id="14" name="decision-context-card">
             <a:extLst xmlns:a="http://schemas.openxmlformats.org/drawingml/2006/main">
               <a:ext uri="{FF2B5EF4-FFF2-40B4-BE49-F238E27FC236}">
-                <a16:creationId xmlns:a16="http://schemas.microsoft.com/office/drawing/2014/main" id="{31F90439-4B6B-459A-9EEB-FF65BC5F6D6E}"/>
+                <a16:creationId xmlns:a16="http://schemas.microsoft.com/office/drawing/2014/main" id="{A40E7CBF-CD0A-4011-A1FF-FDC21EE9FFB8}"/>
               </a:ext>
             </a:extLst>
           </p:cNvPr>
@@ -1581,7 +1617,7 @@
         <p:style>
           <a:lnRef xmlns:a="http://schemas.openxmlformats.org/drawingml/2006/main" idx="0"/>
           <a:fillRef xmlns:a="http://schemas.openxmlformats.org/drawingml/2006/main" idx="0"/>
-          <a:effectRef xmlns:a="http://schemas.openxmlformats.org/drawingml/2006/main" idx="10"/>
+          <a:effectRef xmlns:a="http://schemas.openxmlformats.org/drawingml/2006/main" idx="13"/>
           <a:fontRef xmlns:a="http://schemas.openxmlformats.org/drawingml/2006/main" idx="major"/>
         </p:style>
       </p:sp>
@@ -1590,19 +1626,19 @@
           <p:cNvPr id="15" name="decision-context-title">
             <a:extLst xmlns:a="http://schemas.openxmlformats.org/drawingml/2006/main">
               <a:ext uri="{FF2B5EF4-FFF2-40B4-BE49-F238E27FC236}">
-                <a16:creationId xmlns:a16="http://schemas.microsoft.com/office/drawing/2014/main" id="{F45C8B56-8031-4B01-BDFF-0BFA50AAE8B3}"/>
-              </a:ext>
-            </a:extLst>
-          </p:cNvPr>
-          <p:cNvSpPr>
-            <a:spLocks xmlns:a="http://schemas.openxmlformats.org/drawingml/2006/main" noGrp="1"/>
-          </p:cNvSpPr>
-          <p:nvPr/>
-        </p:nvSpPr>
-        <p:spPr>
-          <a:xfrm xmlns:a="http://schemas.openxmlformats.org/drawingml/2006/main" rot="0">
-            <a:off x="2905125" y="1695450"/>
-            <a:ext cx="6381750" cy="277863"/>
+                <a16:creationId xmlns:a16="http://schemas.microsoft.com/office/drawing/2014/main" id="{F4FB1585-E67B-4B2A-9A36-6441DAE4F040}"/>
+              </a:ext>
+            </a:extLst>
+          </p:cNvPr>
+          <p:cNvSpPr>
+            <a:spLocks xmlns:a="http://schemas.openxmlformats.org/drawingml/2006/main" noGrp="1"/>
+          </p:cNvSpPr>
+          <p:nvPr/>
+        </p:nvSpPr>
+        <p:spPr>
+          <a:xfrm xmlns:a="http://schemas.openxmlformats.org/drawingml/2006/main" rot="0">
+            <a:off x="2905125" y="1700813"/>
+            <a:ext cx="6381750" cy="274882"/>
           </a:xfrm>
           <a:prstGeom xmlns:a="http://schemas.openxmlformats.org/drawingml/2006/main" prst="rect">
             <a:avLst/>
@@ -1614,7 +1650,7 @@
           </a:ln>
         </p:spPr>
         <p:txBody>
-          <a:bodyPr xmlns:a="http://schemas.openxmlformats.org/drawingml/2006/main" lIns="0" tIns="0" rIns="0" bIns="0" anchor="ctr">
+          <a:bodyPr xmlns:a="http://schemas.openxmlformats.org/drawingml/2006/main" wrap="square" lIns="0" tIns="0" rIns="0" bIns="0" anchor="ctr">
             <a:noAutofit/>
           </a:bodyPr>
           <a:lstStyle xmlns:a="http://schemas.openxmlformats.org/drawingml/2006/main"/>
@@ -1624,7 +1660,7 @@
                 <a:spcPct val="114000"/>
               </a:lnSpc>
               <a:buNone/>
-              <a:defRPr sz="2100" b="1" i="0">
+              <a:defRPr sz="1900" b="1" i="0">
                 <a:solidFill>
                   <a:srgbClr val="FFFFFF"/>
                 </a:solidFill>
@@ -1634,7 +1670,7 @@
               </a:defRPr>
             </a:pPr>
             <a:r>
-              <a:rPr sz="2100" b="1" i="0">
+              <a:rPr sz="1900" b="1" i="0">
                 <a:solidFill>
                   <a:srgbClr val="FFFFFF"/>
                 </a:solidFill>
@@ -1652,19 +1688,19 @@
           <p:cNvPr id="16" name="decision-context-body">
             <a:extLst xmlns:a="http://schemas.openxmlformats.org/drawingml/2006/main">
               <a:ext uri="{FF2B5EF4-FFF2-40B4-BE49-F238E27FC236}">
-                <a16:creationId xmlns:a16="http://schemas.microsoft.com/office/drawing/2014/main" id="{DC095558-64C6-44DA-AE42-94CAE1340A97}"/>
-              </a:ext>
-            </a:extLst>
-          </p:cNvPr>
-          <p:cNvSpPr>
-            <a:spLocks xmlns:a="http://schemas.openxmlformats.org/drawingml/2006/main" noGrp="1"/>
-          </p:cNvSpPr>
-          <p:nvPr/>
-        </p:nvSpPr>
-        <p:spPr>
-          <a:xfrm xmlns:a="http://schemas.openxmlformats.org/drawingml/2006/main" rot="0">
-            <a:off x="2905125" y="2020938"/>
-            <a:ext cx="6381750" cy="226962"/>
+                <a16:creationId xmlns:a16="http://schemas.microsoft.com/office/drawing/2014/main" id="{980E308C-49AA-4CCD-B07B-F81981F42A0C}"/>
+              </a:ext>
+            </a:extLst>
+          </p:cNvPr>
+          <p:cNvSpPr>
+            <a:spLocks xmlns:a="http://schemas.openxmlformats.org/drawingml/2006/main" noGrp="1"/>
+          </p:cNvSpPr>
+          <p:nvPr/>
+        </p:nvSpPr>
+        <p:spPr>
+          <a:xfrm xmlns:a="http://schemas.openxmlformats.org/drawingml/2006/main" rot="0">
+            <a:off x="2905125" y="2023320"/>
+            <a:ext cx="6381750" cy="219075"/>
           </a:xfrm>
           <a:prstGeom xmlns:a="http://schemas.openxmlformats.org/drawingml/2006/main" prst="rect">
             <a:avLst/>
@@ -1676,7 +1712,7 @@
           </a:ln>
         </p:spPr>
         <p:txBody>
-          <a:bodyPr xmlns:a="http://schemas.openxmlformats.org/drawingml/2006/main" lIns="0" tIns="0" rIns="0" bIns="0" anchor="ctr">
+          <a:bodyPr xmlns:a="http://schemas.openxmlformats.org/drawingml/2006/main" wrap="square" lIns="0" tIns="0" rIns="0" bIns="0" anchor="ctr">
             <a:noAutofit/>
           </a:bodyPr>
           <a:lstStyle xmlns:a="http://schemas.openxmlformats.org/drawingml/2006/main"/>
@@ -1686,7 +1722,7 @@
                 <a:spcPct val="115000"/>
               </a:lnSpc>
               <a:buNone/>
-              <a:defRPr sz="1700" b="0" i="0">
+              <a:defRPr sz="1500" b="0" i="0">
                 <a:solidFill>
                   <a:srgbClr val="FFFFFF">
                     <a:alpha val="88000"/>
@@ -1698,7 +1734,7 @@
               </a:defRPr>
             </a:pPr>
             <a:r>
-              <a:rPr sz="1700" b="0" i="0">
+              <a:rPr sz="1500" b="0" i="0">
                 <a:solidFill>
                   <a:srgbClr val="FFFFFF">
                     <a:alpha val="88000"/>
@@ -1718,7 +1754,7 @@
           <p:cNvPr id="17" name="branch-route-card-0">
             <a:extLst xmlns:a="http://schemas.openxmlformats.org/drawingml/2006/main">
               <a:ext uri="{FF2B5EF4-FFF2-40B4-BE49-F238E27FC236}">
-                <a16:creationId xmlns:a16="http://schemas.microsoft.com/office/drawing/2014/main" id="{7403624C-E363-44AC-937F-698A7E7EEBF3}"/>
+                <a16:creationId xmlns:a16="http://schemas.microsoft.com/office/drawing/2014/main" id="{C9376CEE-FF4D-47C2-A51E-15948ACD0458}"/>
               </a:ext>
             </a:extLst>
           </p:cNvPr>
@@ -1758,7 +1794,7 @@
         <p:style>
           <a:lnRef xmlns:a="http://schemas.openxmlformats.org/drawingml/2006/main" idx="0"/>
           <a:fillRef xmlns:a="http://schemas.openxmlformats.org/drawingml/2006/main" idx="0"/>
-          <a:effectRef xmlns:a="http://schemas.openxmlformats.org/drawingml/2006/main" idx="11"/>
+          <a:effectRef xmlns:a="http://schemas.openxmlformats.org/drawingml/2006/main" idx="12"/>
           <a:fontRef xmlns:a="http://schemas.openxmlformats.org/drawingml/2006/main" idx="major"/>
         </p:style>
       </p:sp>
@@ -1767,7 +1803,7 @@
           <p:cNvPr id="18" name="branch-route-accent-0">
             <a:extLst xmlns:a="http://schemas.openxmlformats.org/drawingml/2006/main">
               <a:ext uri="{FF2B5EF4-FFF2-40B4-BE49-F238E27FC236}">
-                <a16:creationId xmlns:a16="http://schemas.microsoft.com/office/drawing/2014/main" id="{DBD874AB-FE39-40DE-A979-AC89CE20B194}"/>
+                <a16:creationId xmlns:a16="http://schemas.microsoft.com/office/drawing/2014/main" id="{0A8F1BE6-3258-4D89-B500-BFACD1E153BB}"/>
               </a:ext>
             </a:extLst>
           </p:cNvPr>
@@ -1808,19 +1844,19 @@
           <p:cNvPr id="19" name="branch-title-0">
             <a:extLst xmlns:a="http://schemas.openxmlformats.org/drawingml/2006/main">
               <a:ext uri="{FF2B5EF4-FFF2-40B4-BE49-F238E27FC236}">
-                <a16:creationId xmlns:a16="http://schemas.microsoft.com/office/drawing/2014/main" id="{1265F755-C246-4A89-A687-215BDE343BEC}"/>
-              </a:ext>
-            </a:extLst>
-          </p:cNvPr>
-          <p:cNvSpPr>
-            <a:spLocks xmlns:a="http://schemas.openxmlformats.org/drawingml/2006/main" noGrp="1"/>
-          </p:cNvSpPr>
-          <p:nvPr/>
-        </p:nvSpPr>
-        <p:spPr>
-          <a:xfrm xmlns:a="http://schemas.openxmlformats.org/drawingml/2006/main" rot="0">
-            <a:off x="1743075" y="4467225"/>
-            <a:ext cx="2419350" cy="342900"/>
+                <a16:creationId xmlns:a16="http://schemas.microsoft.com/office/drawing/2014/main" id="{5ABA0046-432C-4416-9267-8EC5B8CAB06A}"/>
+              </a:ext>
+            </a:extLst>
+          </p:cNvPr>
+          <p:cNvSpPr>
+            <a:spLocks xmlns:a="http://schemas.openxmlformats.org/drawingml/2006/main" noGrp="1"/>
+          </p:cNvSpPr>
+          <p:nvPr/>
+        </p:nvSpPr>
+        <p:spPr>
+          <a:xfrm xmlns:a="http://schemas.openxmlformats.org/drawingml/2006/main" rot="0">
+            <a:off x="1743075" y="4564561"/>
+            <a:ext cx="2419350" cy="303905"/>
           </a:xfrm>
           <a:prstGeom xmlns:a="http://schemas.openxmlformats.org/drawingml/2006/main" prst="rect">
             <a:avLst/>
@@ -1832,7 +1868,7 @@
           </a:ln>
         </p:spPr>
         <p:txBody>
-          <a:bodyPr xmlns:a="http://schemas.openxmlformats.org/drawingml/2006/main" lIns="0" tIns="0" rIns="0" bIns="0" anchor="ctr">
+          <a:bodyPr xmlns:a="http://schemas.openxmlformats.org/drawingml/2006/main" wrap="square" lIns="0" tIns="0" rIns="0" bIns="0" anchor="ctr">
             <a:noAutofit/>
           </a:bodyPr>
           <a:lstStyle xmlns:a="http://schemas.openxmlformats.org/drawingml/2006/main"/>
@@ -1842,7 +1878,7 @@
                 <a:spcPct val="114000"/>
               </a:lnSpc>
               <a:buNone/>
-              <a:defRPr sz="1800" b="1" i="0">
+              <a:defRPr sz="2100" b="1" i="0">
                 <a:solidFill>
                   <a:srgbClr val="244B7F"/>
                 </a:solidFill>
@@ -1852,7 +1888,7 @@
               </a:defRPr>
             </a:pPr>
             <a:r>
-              <a:rPr sz="1800" b="1" i="0">
+              <a:rPr sz="2100" b="1" i="0">
                 <a:solidFill>
                   <a:srgbClr val="244B7F"/>
                 </a:solidFill>
@@ -1870,19 +1906,19 @@
           <p:cNvPr id="20" name="branch-body-0">
             <a:extLst xmlns:a="http://schemas.openxmlformats.org/drawingml/2006/main">
               <a:ext uri="{FF2B5EF4-FFF2-40B4-BE49-F238E27FC236}">
-                <a16:creationId xmlns:a16="http://schemas.microsoft.com/office/drawing/2014/main" id="{9A923C4A-E734-40DE-8644-7901D3818557}"/>
-              </a:ext>
-            </a:extLst>
-          </p:cNvPr>
-          <p:cNvSpPr>
-            <a:spLocks xmlns:a="http://schemas.openxmlformats.org/drawingml/2006/main" noGrp="1"/>
-          </p:cNvSpPr>
-          <p:nvPr/>
-        </p:nvSpPr>
-        <p:spPr>
-          <a:xfrm xmlns:a="http://schemas.openxmlformats.org/drawingml/2006/main" rot="0">
-            <a:off x="1743075" y="4876800"/>
-            <a:ext cx="2419350" cy="419100"/>
+                <a16:creationId xmlns:a16="http://schemas.microsoft.com/office/drawing/2014/main" id="{D607EBCD-98FF-4B95-AA1D-83DDA3179B53}"/>
+              </a:ext>
+            </a:extLst>
+          </p:cNvPr>
+          <p:cNvSpPr>
+            <a:spLocks xmlns:a="http://schemas.openxmlformats.org/drawingml/2006/main" noGrp="1"/>
+          </p:cNvSpPr>
+          <p:nvPr/>
+        </p:nvSpPr>
+        <p:spPr>
+          <a:xfrm xmlns:a="http://schemas.openxmlformats.org/drawingml/2006/main" rot="0">
+            <a:off x="1743075" y="4935141"/>
+            <a:ext cx="2419350" cy="263423"/>
           </a:xfrm>
           <a:prstGeom xmlns:a="http://schemas.openxmlformats.org/drawingml/2006/main" prst="rect">
             <a:avLst/>
@@ -1894,7 +1930,7 @@
           </a:ln>
         </p:spPr>
         <p:txBody>
-          <a:bodyPr xmlns:a="http://schemas.openxmlformats.org/drawingml/2006/main" lIns="0" tIns="0" rIns="0" bIns="0" anchor="t">
+          <a:bodyPr xmlns:a="http://schemas.openxmlformats.org/drawingml/2006/main" wrap="square" lIns="0" tIns="0" rIns="0" bIns="0" anchor="ctr">
             <a:noAutofit/>
           </a:bodyPr>
           <a:lstStyle xmlns:a="http://schemas.openxmlformats.org/drawingml/2006/main"/>
@@ -1932,7 +1968,7 @@
           <p:cNvPr id="21" name="branch-route-card-1">
             <a:extLst xmlns:a="http://schemas.openxmlformats.org/drawingml/2006/main">
               <a:ext uri="{FF2B5EF4-FFF2-40B4-BE49-F238E27FC236}">
-                <a16:creationId xmlns:a16="http://schemas.microsoft.com/office/drawing/2014/main" id="{78940DD1-AA30-4CD1-A289-A86143880855}"/>
+                <a16:creationId xmlns:a16="http://schemas.microsoft.com/office/drawing/2014/main" id="{78616363-DF60-4A96-813D-5F50CA76ADE5}"/>
               </a:ext>
             </a:extLst>
           </p:cNvPr>
@@ -1972,7 +2008,7 @@
         <p:style>
           <a:lnRef xmlns:a="http://schemas.openxmlformats.org/drawingml/2006/main" idx="0"/>
           <a:fillRef xmlns:a="http://schemas.openxmlformats.org/drawingml/2006/main" idx="0"/>
-          <a:effectRef xmlns:a="http://schemas.openxmlformats.org/drawingml/2006/main" idx="11"/>
+          <a:effectRef xmlns:a="http://schemas.openxmlformats.org/drawingml/2006/main" idx="12"/>
           <a:fontRef xmlns:a="http://schemas.openxmlformats.org/drawingml/2006/main" idx="major"/>
         </p:style>
       </p:sp>
@@ -1981,7 +2017,7 @@
           <p:cNvPr id="22" name="branch-route-accent-1">
             <a:extLst xmlns:a="http://schemas.openxmlformats.org/drawingml/2006/main">
               <a:ext uri="{FF2B5EF4-FFF2-40B4-BE49-F238E27FC236}">
-                <a16:creationId xmlns:a16="http://schemas.microsoft.com/office/drawing/2014/main" id="{6FED66F5-941D-405A-A917-0DE673F347B4}"/>
+                <a16:creationId xmlns:a16="http://schemas.microsoft.com/office/drawing/2014/main" id="{CE2AD520-C794-4712-BCF4-9D8BB0B0691A}"/>
               </a:ext>
             </a:extLst>
           </p:cNvPr>
@@ -2022,19 +2058,19 @@
           <p:cNvPr id="23" name="branch-title-1">
             <a:extLst xmlns:a="http://schemas.openxmlformats.org/drawingml/2006/main">
               <a:ext uri="{FF2B5EF4-FFF2-40B4-BE49-F238E27FC236}">
-                <a16:creationId xmlns:a16="http://schemas.microsoft.com/office/drawing/2014/main" id="{489B58A2-CDA8-4271-8494-C34B8C5FED71}"/>
-              </a:ext>
-            </a:extLst>
-          </p:cNvPr>
-          <p:cNvSpPr>
-            <a:spLocks xmlns:a="http://schemas.openxmlformats.org/drawingml/2006/main" noGrp="1"/>
-          </p:cNvSpPr>
-          <p:nvPr/>
-        </p:nvSpPr>
-        <p:spPr>
-          <a:xfrm xmlns:a="http://schemas.openxmlformats.org/drawingml/2006/main" rot="0">
-            <a:off x="4886325" y="4413352"/>
-            <a:ext cx="2419350" cy="342900"/>
+                <a16:creationId xmlns:a16="http://schemas.microsoft.com/office/drawing/2014/main" id="{C4EEA05A-CB88-49BB-BBFF-258C756E5DD5}"/>
+              </a:ext>
+            </a:extLst>
+          </p:cNvPr>
+          <p:cNvSpPr>
+            <a:spLocks xmlns:a="http://schemas.openxmlformats.org/drawingml/2006/main" noGrp="1"/>
+          </p:cNvSpPr>
+          <p:nvPr/>
+        </p:nvSpPr>
+        <p:spPr>
+          <a:xfrm xmlns:a="http://schemas.openxmlformats.org/drawingml/2006/main" rot="0">
+            <a:off x="4886325" y="4432849"/>
+            <a:ext cx="2419350" cy="303905"/>
           </a:xfrm>
           <a:prstGeom xmlns:a="http://schemas.openxmlformats.org/drawingml/2006/main" prst="rect">
             <a:avLst/>
@@ -2046,7 +2082,7 @@
           </a:ln>
         </p:spPr>
         <p:txBody>
-          <a:bodyPr xmlns:a="http://schemas.openxmlformats.org/drawingml/2006/main" lIns="0" tIns="0" rIns="0" bIns="0" anchor="ctr">
+          <a:bodyPr xmlns:a="http://schemas.openxmlformats.org/drawingml/2006/main" wrap="square" lIns="0" tIns="0" rIns="0" bIns="0" anchor="ctr">
             <a:noAutofit/>
           </a:bodyPr>
           <a:lstStyle xmlns:a="http://schemas.openxmlformats.org/drawingml/2006/main"/>
@@ -2056,7 +2092,7 @@
                 <a:spcPct val="114000"/>
               </a:lnSpc>
               <a:buNone/>
-              <a:defRPr sz="1800" b="1" i="0">
+              <a:defRPr sz="2100" b="1" i="0">
                 <a:solidFill>
                   <a:srgbClr val="244B7F"/>
                 </a:solidFill>
@@ -2066,7 +2102,7 @@
               </a:defRPr>
             </a:pPr>
             <a:r>
-              <a:rPr sz="1800" b="1" i="0">
+              <a:rPr sz="2100" b="1" i="0">
                 <a:solidFill>
                   <a:srgbClr val="244B7F"/>
                 </a:solidFill>
@@ -2084,18 +2120,18 @@
           <p:cNvPr id="24" name="branch-body-1">
             <a:extLst xmlns:a="http://schemas.openxmlformats.org/drawingml/2006/main">
               <a:ext uri="{FF2B5EF4-FFF2-40B4-BE49-F238E27FC236}">
-                <a16:creationId xmlns:a16="http://schemas.microsoft.com/office/drawing/2014/main" id="{B5029A2B-0639-46BA-BF44-9B5238E2A95C}"/>
-              </a:ext>
-            </a:extLst>
-          </p:cNvPr>
-          <p:cNvSpPr>
-            <a:spLocks xmlns:a="http://schemas.openxmlformats.org/drawingml/2006/main" noGrp="1"/>
-          </p:cNvSpPr>
-          <p:nvPr/>
-        </p:nvSpPr>
-        <p:spPr>
-          <a:xfrm xmlns:a="http://schemas.openxmlformats.org/drawingml/2006/main" rot="0">
-            <a:off x="4886325" y="4822927"/>
+                <a16:creationId xmlns:a16="http://schemas.microsoft.com/office/drawing/2014/main" id="{BB57798E-A821-452D-84BE-EE7CD3D3DA19}"/>
+              </a:ext>
+            </a:extLst>
+          </p:cNvPr>
+          <p:cNvSpPr>
+            <a:spLocks xmlns:a="http://schemas.openxmlformats.org/drawingml/2006/main" noGrp="1"/>
+          </p:cNvSpPr>
+          <p:nvPr/>
+        </p:nvSpPr>
+        <p:spPr>
+          <a:xfrm xmlns:a="http://schemas.openxmlformats.org/drawingml/2006/main" rot="0">
+            <a:off x="4886325" y="4803429"/>
             <a:ext cx="2419350" cy="526856"/>
           </a:xfrm>
           <a:prstGeom xmlns:a="http://schemas.openxmlformats.org/drawingml/2006/main" prst="rect">
@@ -2108,7 +2144,7 @@
           </a:ln>
         </p:spPr>
         <p:txBody>
-          <a:bodyPr xmlns:a="http://schemas.openxmlformats.org/drawingml/2006/main" lIns="0" tIns="0" rIns="0" bIns="0" anchor="t">
+          <a:bodyPr xmlns:a="http://schemas.openxmlformats.org/drawingml/2006/main" wrap="square" lIns="0" tIns="0" rIns="0" bIns="0" anchor="ctr">
             <a:noAutofit/>
           </a:bodyPr>
           <a:lstStyle xmlns:a="http://schemas.openxmlformats.org/drawingml/2006/main"/>
@@ -2136,7 +2172,34 @@
                 <a:ea typeface="Microsoft YaHei"/>
                 <a:cs typeface="Microsoft YaHei"/>
               </a:rPr>
-              <a:t>明确缺失项并保留当前进度</a:t>
+              <a:t>明确缺失项并保留当前进</a:t>
+            </a:r>
+          </a:p>
+          <a:p xmlns:a="http://schemas.openxmlformats.org/drawingml/2006/main">
+            <a:pPr algn="ctr">
+              <a:lnSpc>
+                <a:spcPct val="122000"/>
+              </a:lnSpc>
+              <a:buNone/>
+              <a:defRPr sz="1700" b="0" i="0">
+                <a:solidFill>
+                  <a:srgbClr val="536981"/>
+                </a:solidFill>
+                <a:latin typeface="Microsoft YaHei"/>
+                <a:ea typeface="Microsoft YaHei"/>
+                <a:cs typeface="Microsoft YaHei"/>
+              </a:defRPr>
+            </a:pPr>
+            <a:r>
+              <a:rPr sz="1700" b="0" i="0">
+                <a:solidFill>
+                  <a:srgbClr val="536981"/>
+                </a:solidFill>
+                <a:latin typeface="Microsoft YaHei"/>
+                <a:ea typeface="Microsoft YaHei"/>
+                <a:cs typeface="Microsoft YaHei"/>
+              </a:rPr>
+              <a:t>度</a:t>
             </a:r>
           </a:p>
         </p:txBody>
@@ -2146,7 +2209,7 @@
           <p:cNvPr id="25" name="branch-route-card-2">
             <a:extLst xmlns:a="http://schemas.openxmlformats.org/drawingml/2006/main">
               <a:ext uri="{FF2B5EF4-FFF2-40B4-BE49-F238E27FC236}">
-                <a16:creationId xmlns:a16="http://schemas.microsoft.com/office/drawing/2014/main" id="{4E4E0B3E-E547-4AFB-8662-854B81B21EE4}"/>
+                <a16:creationId xmlns:a16="http://schemas.microsoft.com/office/drawing/2014/main" id="{9ECA443C-8C69-4887-A615-3C0BE3A5FC08}"/>
               </a:ext>
             </a:extLst>
           </p:cNvPr>
@@ -2186,7 +2249,7 @@
         <p:style>
           <a:lnRef xmlns:a="http://schemas.openxmlformats.org/drawingml/2006/main" idx="0"/>
           <a:fillRef xmlns:a="http://schemas.openxmlformats.org/drawingml/2006/main" idx="0"/>
-          <a:effectRef xmlns:a="http://schemas.openxmlformats.org/drawingml/2006/main" idx="11"/>
+          <a:effectRef xmlns:a="http://schemas.openxmlformats.org/drawingml/2006/main" idx="12"/>
           <a:fontRef xmlns:a="http://schemas.openxmlformats.org/drawingml/2006/main" idx="major"/>
         </p:style>
       </p:sp>
@@ -2195,7 +2258,7 @@
           <p:cNvPr id="26" name="branch-route-accent-2">
             <a:extLst xmlns:a="http://schemas.openxmlformats.org/drawingml/2006/main">
               <a:ext uri="{FF2B5EF4-FFF2-40B4-BE49-F238E27FC236}">
-                <a16:creationId xmlns:a16="http://schemas.microsoft.com/office/drawing/2014/main" id="{E0974245-8DF0-46B4-B265-6209E686B889}"/>
+                <a16:creationId xmlns:a16="http://schemas.microsoft.com/office/drawing/2014/main" id="{5A107632-8321-47BA-916A-028B09754712}"/>
               </a:ext>
             </a:extLst>
           </p:cNvPr>
@@ -2236,19 +2299,19 @@
           <p:cNvPr id="27" name="branch-title-2">
             <a:extLst xmlns:a="http://schemas.openxmlformats.org/drawingml/2006/main">
               <a:ext uri="{FF2B5EF4-FFF2-40B4-BE49-F238E27FC236}">
-                <a16:creationId xmlns:a16="http://schemas.microsoft.com/office/drawing/2014/main" id="{A4AEE700-464A-4129-A23D-D17BA83ABCAE}"/>
-              </a:ext>
-            </a:extLst>
-          </p:cNvPr>
-          <p:cNvSpPr>
-            <a:spLocks xmlns:a="http://schemas.openxmlformats.org/drawingml/2006/main" noGrp="1"/>
-          </p:cNvSpPr>
-          <p:nvPr/>
-        </p:nvSpPr>
-        <p:spPr>
-          <a:xfrm xmlns:a="http://schemas.openxmlformats.org/drawingml/2006/main" rot="0">
-            <a:off x="8029575" y="4413352"/>
-            <a:ext cx="2419350" cy="342900"/>
+                <a16:creationId xmlns:a16="http://schemas.microsoft.com/office/drawing/2014/main" id="{612087C6-32D3-4675-BD07-6A1DFE3AC9C3}"/>
+              </a:ext>
+            </a:extLst>
+          </p:cNvPr>
+          <p:cNvSpPr>
+            <a:spLocks xmlns:a="http://schemas.openxmlformats.org/drawingml/2006/main" noGrp="1"/>
+          </p:cNvSpPr>
+          <p:nvPr/>
+        </p:nvSpPr>
+        <p:spPr>
+          <a:xfrm xmlns:a="http://schemas.openxmlformats.org/drawingml/2006/main" rot="0">
+            <a:off x="8029575" y="4432849"/>
+            <a:ext cx="2419350" cy="303905"/>
           </a:xfrm>
           <a:prstGeom xmlns:a="http://schemas.openxmlformats.org/drawingml/2006/main" prst="rect">
             <a:avLst/>
@@ -2260,7 +2323,7 @@
           </a:ln>
         </p:spPr>
         <p:txBody>
-          <a:bodyPr xmlns:a="http://schemas.openxmlformats.org/drawingml/2006/main" lIns="0" tIns="0" rIns="0" bIns="0" anchor="ctr">
+          <a:bodyPr xmlns:a="http://schemas.openxmlformats.org/drawingml/2006/main" wrap="square" lIns="0" tIns="0" rIns="0" bIns="0" anchor="ctr">
             <a:noAutofit/>
           </a:bodyPr>
           <a:lstStyle xmlns:a="http://schemas.openxmlformats.org/drawingml/2006/main"/>
@@ -2270,7 +2333,7 @@
                 <a:spcPct val="114000"/>
               </a:lnSpc>
               <a:buNone/>
-              <a:defRPr sz="1800" b="1" i="0">
+              <a:defRPr sz="2100" b="1" i="0">
                 <a:solidFill>
                   <a:srgbClr val="244B7F"/>
                 </a:solidFill>
@@ -2280,7 +2343,7 @@
               </a:defRPr>
             </a:pPr>
             <a:r>
-              <a:rPr sz="1800" b="1" i="0">
+              <a:rPr sz="2100" b="1" i="0">
                 <a:solidFill>
                   <a:srgbClr val="244B7F"/>
                 </a:solidFill>
@@ -2298,18 +2361,18 @@
           <p:cNvPr id="28" name="branch-body-2">
             <a:extLst xmlns:a="http://schemas.openxmlformats.org/drawingml/2006/main">
               <a:ext uri="{FF2B5EF4-FFF2-40B4-BE49-F238E27FC236}">
-                <a16:creationId xmlns:a16="http://schemas.microsoft.com/office/drawing/2014/main" id="{C5CB20B2-05FC-48DF-B061-FCD27ED6ACBF}"/>
-              </a:ext>
-            </a:extLst>
-          </p:cNvPr>
-          <p:cNvSpPr>
-            <a:spLocks xmlns:a="http://schemas.openxmlformats.org/drawingml/2006/main" noGrp="1"/>
-          </p:cNvSpPr>
-          <p:nvPr/>
-        </p:nvSpPr>
-        <p:spPr>
-          <a:xfrm xmlns:a="http://schemas.openxmlformats.org/drawingml/2006/main" rot="0">
-            <a:off x="8029575" y="4822927"/>
+                <a16:creationId xmlns:a16="http://schemas.microsoft.com/office/drawing/2014/main" id="{9EEB810B-4EAC-465C-A437-D6F249F90E58}"/>
+              </a:ext>
+            </a:extLst>
+          </p:cNvPr>
+          <p:cNvSpPr>
+            <a:spLocks xmlns:a="http://schemas.openxmlformats.org/drawingml/2006/main" noGrp="1"/>
+          </p:cNvSpPr>
+          <p:nvPr/>
+        </p:nvSpPr>
+        <p:spPr>
+          <a:xfrm xmlns:a="http://schemas.openxmlformats.org/drawingml/2006/main" rot="0">
+            <a:off x="8029575" y="4803429"/>
             <a:ext cx="2419350" cy="526856"/>
           </a:xfrm>
           <a:prstGeom xmlns:a="http://schemas.openxmlformats.org/drawingml/2006/main" prst="rect">
@@ -2322,7 +2385,7 @@
           </a:ln>
         </p:spPr>
         <p:txBody>
-          <a:bodyPr xmlns:a="http://schemas.openxmlformats.org/drawingml/2006/main" lIns="0" tIns="0" rIns="0" bIns="0" anchor="t">
+          <a:bodyPr xmlns:a="http://schemas.openxmlformats.org/drawingml/2006/main" wrap="square" lIns="0" tIns="0" rIns="0" bIns="0" anchor="ctr">
             <a:noAutofit/>
           </a:bodyPr>
           <a:lstStyle xmlns:a="http://schemas.openxmlformats.org/drawingml/2006/main"/>
@@ -2350,7 +2413,34 @@
                 <a:ea typeface="Microsoft YaHei"/>
                 <a:cs typeface="Microsoft YaHei"/>
               </a:rPr>
-              <a:t>由责任人判断是否继续处理</a:t>
+              <a:t>由责任人判断是否继续处</a:t>
+            </a:r>
+          </a:p>
+          <a:p xmlns:a="http://schemas.openxmlformats.org/drawingml/2006/main">
+            <a:pPr algn="ctr">
+              <a:lnSpc>
+                <a:spcPct val="122000"/>
+              </a:lnSpc>
+              <a:buNone/>
+              <a:defRPr sz="1700" b="0" i="0">
+                <a:solidFill>
+                  <a:srgbClr val="536981"/>
+                </a:solidFill>
+                <a:latin typeface="Microsoft YaHei"/>
+                <a:ea typeface="Microsoft YaHei"/>
+                <a:cs typeface="Microsoft YaHei"/>
+              </a:defRPr>
+            </a:pPr>
+            <a:r>
+              <a:rPr sz="1700" b="0" i="0">
+                <a:solidFill>
+                  <a:srgbClr val="536981"/>
+                </a:solidFill>
+                <a:latin typeface="Microsoft YaHei"/>
+                <a:ea typeface="Microsoft YaHei"/>
+                <a:cs typeface="Microsoft YaHei"/>
+              </a:rPr>
+              <a:t>理</a:t>
             </a:r>
           </a:p>
         </p:txBody>
@@ -2360,7 +2450,7 @@
           <p:cNvPr id="29" name="branch-outcome-0">
             <a:extLst xmlns:a="http://schemas.openxmlformats.org/drawingml/2006/main">
               <a:ext uri="{FF2B5EF4-FFF2-40B4-BE49-F238E27FC236}">
-                <a16:creationId xmlns:a16="http://schemas.microsoft.com/office/drawing/2014/main" id="{97B4320B-5AA2-4015-812B-0FF6A58CFCE5}"/>
+                <a16:creationId xmlns:a16="http://schemas.microsoft.com/office/drawing/2014/main" id="{F193FD6A-00CE-4ACF-A630-2EE306D6873D}"/>
               </a:ext>
             </a:extLst>
           </p:cNvPr>
@@ -2392,11 +2482,11 @@
         <p:style>
           <a:lnRef xmlns:a="http://schemas.openxmlformats.org/drawingml/2006/main" idx="0"/>
           <a:fillRef xmlns:a="http://schemas.openxmlformats.org/drawingml/2006/main" idx="0"/>
-          <a:effectRef xmlns:a="http://schemas.openxmlformats.org/drawingml/2006/main" idx="12"/>
+          <a:effectRef xmlns:a="http://schemas.openxmlformats.org/drawingml/2006/main" idx="14"/>
           <a:fontRef xmlns:a="http://schemas.openxmlformats.org/drawingml/2006/main" idx="major"/>
         </p:style>
         <p:txBody>
-          <a:bodyPr xmlns:a="http://schemas.openxmlformats.org/drawingml/2006/main" lIns="0" tIns="0" rIns="0" bIns="0" anchor="ctr">
+          <a:bodyPr xmlns:a="http://schemas.openxmlformats.org/drawingml/2006/main" wrap="none" lIns="0" tIns="0" rIns="0" bIns="0" anchor="ctr">
             <a:noAutofit/>
           </a:bodyPr>
           <a:lstStyle xmlns:a="http://schemas.openxmlformats.org/drawingml/2006/main"/>
@@ -2406,7 +2496,7 @@
                 <a:spcPct val="110000"/>
               </a:lnSpc>
               <a:buNone/>
-              <a:defRPr sz="1700" b="1" i="0">
+              <a:defRPr sz="1500" b="1" i="0">
                 <a:solidFill>
                   <a:srgbClr val="2C5D99"/>
                 </a:solidFill>
@@ -2416,7 +2506,7 @@
               </a:defRPr>
             </a:pPr>
             <a:r>
-              <a:rPr sz="1700" b="1" i="0">
+              <a:rPr sz="1500" b="1" i="0">
                 <a:solidFill>
                   <a:srgbClr val="2C5D99"/>
                 </a:solidFill>
@@ -2434,7 +2524,7 @@
           <p:cNvPr id="30" name="branch-outcome-1">
             <a:extLst xmlns:a="http://schemas.openxmlformats.org/drawingml/2006/main">
               <a:ext uri="{FF2B5EF4-FFF2-40B4-BE49-F238E27FC236}">
-                <a16:creationId xmlns:a16="http://schemas.microsoft.com/office/drawing/2014/main" id="{E28898F3-D102-46B5-83C0-BF3190B888FF}"/>
+                <a16:creationId xmlns:a16="http://schemas.microsoft.com/office/drawing/2014/main" id="{A47F3792-D7A5-4E91-AA14-77C5226BECB3}"/>
               </a:ext>
             </a:extLst>
           </p:cNvPr>
@@ -2466,11 +2556,11 @@
         <p:style>
           <a:lnRef xmlns:a="http://schemas.openxmlformats.org/drawingml/2006/main" idx="0"/>
           <a:fillRef xmlns:a="http://schemas.openxmlformats.org/drawingml/2006/main" idx="0"/>
-          <a:effectRef xmlns:a="http://schemas.openxmlformats.org/drawingml/2006/main" idx="12"/>
+          <a:effectRef xmlns:a="http://schemas.openxmlformats.org/drawingml/2006/main" idx="14"/>
           <a:fontRef xmlns:a="http://schemas.openxmlformats.org/drawingml/2006/main" idx="major"/>
         </p:style>
         <p:txBody>
-          <a:bodyPr xmlns:a="http://schemas.openxmlformats.org/drawingml/2006/main" lIns="0" tIns="0" rIns="0" bIns="0" anchor="ctr">
+          <a:bodyPr xmlns:a="http://schemas.openxmlformats.org/drawingml/2006/main" wrap="none" lIns="0" tIns="0" rIns="0" bIns="0" anchor="ctr">
             <a:noAutofit/>
           </a:bodyPr>
           <a:lstStyle xmlns:a="http://schemas.openxmlformats.org/drawingml/2006/main"/>
@@ -2480,7 +2570,7 @@
                 <a:spcPct val="110000"/>
               </a:lnSpc>
               <a:buNone/>
-              <a:defRPr sz="1700" b="1" i="0">
+              <a:defRPr sz="1500" b="1" i="0">
                 <a:solidFill>
                   <a:srgbClr val="2C5D99"/>
                 </a:solidFill>
@@ -2490,7 +2580,7 @@
               </a:defRPr>
             </a:pPr>
             <a:r>
-              <a:rPr sz="1700" b="1" i="0">
+              <a:rPr sz="1500" b="1" i="0">
                 <a:solidFill>
                   <a:srgbClr val="2C5D99"/>
                 </a:solidFill>
@@ -2508,7 +2598,7 @@
           <p:cNvPr id="31" name="branch-outcome-2">
             <a:extLst xmlns:a="http://schemas.openxmlformats.org/drawingml/2006/main">
               <a:ext uri="{FF2B5EF4-FFF2-40B4-BE49-F238E27FC236}">
-                <a16:creationId xmlns:a16="http://schemas.microsoft.com/office/drawing/2014/main" id="{18362A69-61AA-4D09-88BE-A8610FC1E115}"/>
+                <a16:creationId xmlns:a16="http://schemas.microsoft.com/office/drawing/2014/main" id="{B8B01EB0-A07E-48A3-8F2C-B21BDC119BBF}"/>
               </a:ext>
             </a:extLst>
           </p:cNvPr>
@@ -2540,11 +2630,11 @@
         <p:style>
           <a:lnRef xmlns:a="http://schemas.openxmlformats.org/drawingml/2006/main" idx="0"/>
           <a:fillRef xmlns:a="http://schemas.openxmlformats.org/drawingml/2006/main" idx="0"/>
-          <a:effectRef xmlns:a="http://schemas.openxmlformats.org/drawingml/2006/main" idx="12"/>
+          <a:effectRef xmlns:a="http://schemas.openxmlformats.org/drawingml/2006/main" idx="14"/>
           <a:fontRef xmlns:a="http://schemas.openxmlformats.org/drawingml/2006/main" idx="major"/>
         </p:style>
         <p:txBody>
-          <a:bodyPr xmlns:a="http://schemas.openxmlformats.org/drawingml/2006/main" lIns="0" tIns="0" rIns="0" bIns="0" anchor="ctr">
+          <a:bodyPr xmlns:a="http://schemas.openxmlformats.org/drawingml/2006/main" wrap="none" lIns="0" tIns="0" rIns="0" bIns="0" anchor="ctr">
             <a:noAutofit/>
           </a:bodyPr>
           <a:lstStyle xmlns:a="http://schemas.openxmlformats.org/drawingml/2006/main"/>
@@ -2554,7 +2644,7 @@
                 <a:spcPct val="110000"/>
               </a:lnSpc>
               <a:buNone/>
-              <a:defRPr sz="1700" b="1" i="0">
+              <a:defRPr sz="1500" b="1" i="0">
                 <a:solidFill>
                   <a:srgbClr val="2C5D99"/>
                 </a:solidFill>
@@ -2564,7 +2654,7 @@
               </a:defRPr>
             </a:pPr>
             <a:r>
-              <a:rPr sz="1700" b="1" i="0">
+              <a:rPr sz="1500" b="1" i="0">
                 <a:solidFill>
                   <a:srgbClr val="2C5D99"/>
                 </a:solidFill>
@@ -2582,7 +2672,7 @@
           <p:cNvPr id="32" name="branch-condition-0">
             <a:extLst xmlns:a="http://schemas.openxmlformats.org/drawingml/2006/main">
               <a:ext uri="{FF2B5EF4-FFF2-40B4-BE49-F238E27FC236}">
-                <a16:creationId xmlns:a16="http://schemas.microsoft.com/office/drawing/2014/main" id="{24F01A93-658A-4022-85E1-FBEBB0056DB9}"/>
+                <a16:creationId xmlns:a16="http://schemas.microsoft.com/office/drawing/2014/main" id="{1DBA0613-8783-48B9-99B2-D3C180CD671D}"/>
               </a:ext>
             </a:extLst>
           </p:cNvPr>
@@ -2614,11 +2704,11 @@
         <p:style>
           <a:lnRef xmlns:a="http://schemas.openxmlformats.org/drawingml/2006/main" idx="0"/>
           <a:fillRef xmlns:a="http://schemas.openxmlformats.org/drawingml/2006/main" idx="0"/>
-          <a:effectRef xmlns:a="http://schemas.openxmlformats.org/drawingml/2006/main" idx="13"/>
+          <a:effectRef xmlns:a="http://schemas.openxmlformats.org/drawingml/2006/main" idx="15"/>
           <a:fontRef xmlns:a="http://schemas.openxmlformats.org/drawingml/2006/main" idx="major"/>
         </p:style>
         <p:txBody>
-          <a:bodyPr xmlns:a="http://schemas.openxmlformats.org/drawingml/2006/main" lIns="0" tIns="0" rIns="0" bIns="0" anchor="ctr">
+          <a:bodyPr xmlns:a="http://schemas.openxmlformats.org/drawingml/2006/main" wrap="none" lIns="0" tIns="0" rIns="0" bIns="0" anchor="ctr">
             <a:noAutofit/>
           </a:bodyPr>
           <a:lstStyle xmlns:a="http://schemas.openxmlformats.org/drawingml/2006/main"/>
@@ -2628,7 +2718,7 @@
                 <a:spcPct val="100000"/>
               </a:lnSpc>
               <a:buNone/>
-              <a:defRPr sz="1700" b="1" i="0">
+              <a:defRPr sz="1500" b="1" i="0">
                 <a:solidFill>
                   <a:srgbClr val="315F9E"/>
                 </a:solidFill>
@@ -2638,7 +2728,7 @@
               </a:defRPr>
             </a:pPr>
             <a:r>
-              <a:rPr sz="1700" b="1" i="0">
+              <a:rPr sz="1500" b="1" i="0">
                 <a:solidFill>
                   <a:srgbClr val="315F9E"/>
                 </a:solidFill>
@@ -2656,7 +2746,7 @@
           <p:cNvPr id="33" name="branch-condition-1">
             <a:extLst xmlns:a="http://schemas.openxmlformats.org/drawingml/2006/main">
               <a:ext uri="{FF2B5EF4-FFF2-40B4-BE49-F238E27FC236}">
-                <a16:creationId xmlns:a16="http://schemas.microsoft.com/office/drawing/2014/main" id="{1205C75D-58E2-4137-B2D1-445CB73252EA}"/>
+                <a16:creationId xmlns:a16="http://schemas.microsoft.com/office/drawing/2014/main" id="{B2A376AF-9F3C-47F5-B55D-C05ED1E99910}"/>
               </a:ext>
             </a:extLst>
           </p:cNvPr>
@@ -2688,11 +2778,11 @@
         <p:style>
           <a:lnRef xmlns:a="http://schemas.openxmlformats.org/drawingml/2006/main" idx="0"/>
           <a:fillRef xmlns:a="http://schemas.openxmlformats.org/drawingml/2006/main" idx="0"/>
-          <a:effectRef xmlns:a="http://schemas.openxmlformats.org/drawingml/2006/main" idx="13"/>
+          <a:effectRef xmlns:a="http://schemas.openxmlformats.org/drawingml/2006/main" idx="15"/>
           <a:fontRef xmlns:a="http://schemas.openxmlformats.org/drawingml/2006/main" idx="major"/>
         </p:style>
         <p:txBody>
-          <a:bodyPr xmlns:a="http://schemas.openxmlformats.org/drawingml/2006/main" lIns="0" tIns="0" rIns="0" bIns="0" anchor="ctr">
+          <a:bodyPr xmlns:a="http://schemas.openxmlformats.org/drawingml/2006/main" wrap="none" lIns="0" tIns="0" rIns="0" bIns="0" anchor="ctr">
             <a:noAutofit/>
           </a:bodyPr>
           <a:lstStyle xmlns:a="http://schemas.openxmlformats.org/drawingml/2006/main"/>
@@ -2702,7 +2792,7 @@
                 <a:spcPct val="100000"/>
               </a:lnSpc>
               <a:buNone/>
-              <a:defRPr sz="1700" b="1" i="0">
+              <a:defRPr sz="1500" b="1" i="0">
                 <a:solidFill>
                   <a:srgbClr val="315F9E"/>
                 </a:solidFill>
@@ -2712,7 +2802,7 @@
               </a:defRPr>
             </a:pPr>
             <a:r>
-              <a:rPr sz="1700" b="1" i="0">
+              <a:rPr sz="1500" b="1" i="0">
                 <a:solidFill>
                   <a:srgbClr val="315F9E"/>
                 </a:solidFill>
@@ -2730,7 +2820,7 @@
           <p:cNvPr id="34" name="branch-condition-2">
             <a:extLst xmlns:a="http://schemas.openxmlformats.org/drawingml/2006/main">
               <a:ext uri="{FF2B5EF4-FFF2-40B4-BE49-F238E27FC236}">
-                <a16:creationId xmlns:a16="http://schemas.microsoft.com/office/drawing/2014/main" id="{24ABD3CD-8949-4F13-B9C8-F3BFC072F290}"/>
+                <a16:creationId xmlns:a16="http://schemas.microsoft.com/office/drawing/2014/main" id="{2CECF07F-4A63-484E-859B-C43E2C836B24}"/>
               </a:ext>
             </a:extLst>
           </p:cNvPr>
@@ -2762,11 +2852,11 @@
         <p:style>
           <a:lnRef xmlns:a="http://schemas.openxmlformats.org/drawingml/2006/main" idx="0"/>
           <a:fillRef xmlns:a="http://schemas.openxmlformats.org/drawingml/2006/main" idx="0"/>
-          <a:effectRef xmlns:a="http://schemas.openxmlformats.org/drawingml/2006/main" idx="13"/>
+          <a:effectRef xmlns:a="http://schemas.openxmlformats.org/drawingml/2006/main" idx="15"/>
           <a:fontRef xmlns:a="http://schemas.openxmlformats.org/drawingml/2006/main" idx="major"/>
         </p:style>
         <p:txBody>
-          <a:bodyPr xmlns:a="http://schemas.openxmlformats.org/drawingml/2006/main" lIns="0" tIns="0" rIns="0" bIns="0" anchor="ctr">
+          <a:bodyPr xmlns:a="http://schemas.openxmlformats.org/drawingml/2006/main" wrap="none" lIns="0" tIns="0" rIns="0" bIns="0" anchor="ctr">
             <a:noAutofit/>
           </a:bodyPr>
           <a:lstStyle xmlns:a="http://schemas.openxmlformats.org/drawingml/2006/main"/>
@@ -2776,7 +2866,7 @@
                 <a:spcPct val="100000"/>
               </a:lnSpc>
               <a:buNone/>
-              <a:defRPr sz="1700" b="1" i="0">
+              <a:defRPr sz="1500" b="1" i="0">
                 <a:solidFill>
                   <a:srgbClr val="315F9E"/>
                 </a:solidFill>
@@ -2786,7 +2876,7 @@
               </a:defRPr>
             </a:pPr>
             <a:r>
-              <a:rPr sz="1700" b="1" i="0">
+              <a:rPr sz="1500" b="1" i="0">
                 <a:solidFill>
                   <a:srgbClr val="315F9E"/>
                 </a:solidFill>
@@ -2804,19 +2894,19 @@
           <p:cNvPr id="35" name="decision-node">
             <a:extLst xmlns:a="http://schemas.openxmlformats.org/drawingml/2006/main">
               <a:ext uri="{FF2B5EF4-FFF2-40B4-BE49-F238E27FC236}">
-                <a16:creationId xmlns:a16="http://schemas.microsoft.com/office/drawing/2014/main" id="{1F2C1521-A09C-483C-ADD4-9499A235B148}"/>
-              </a:ext>
-            </a:extLst>
-          </p:cNvPr>
-          <p:cNvSpPr>
-            <a:spLocks xmlns:a="http://schemas.openxmlformats.org/drawingml/2006/main" noGrp="1"/>
-          </p:cNvSpPr>
-          <p:nvPr/>
-        </p:nvSpPr>
-        <p:spPr>
-          <a:xfrm xmlns:a="http://schemas.openxmlformats.org/drawingml/2006/main" rot="0">
-            <a:off x="5267325" y="2571750"/>
-            <a:ext cx="1657350" cy="1047750"/>
+                <a16:creationId xmlns:a16="http://schemas.microsoft.com/office/drawing/2014/main" id="{2F2DDAC3-6934-4AAB-B208-3B2220ACA8EF}"/>
+              </a:ext>
+            </a:extLst>
+          </p:cNvPr>
+          <p:cNvSpPr>
+            <a:spLocks xmlns:a="http://schemas.openxmlformats.org/drawingml/2006/main" noGrp="1"/>
+          </p:cNvSpPr>
+          <p:nvPr/>
+        </p:nvSpPr>
+        <p:spPr>
+          <a:xfrm xmlns:a="http://schemas.openxmlformats.org/drawingml/2006/main" rot="0">
+            <a:off x="5048250" y="2571750"/>
+            <a:ext cx="2095500" cy="1047750"/>
           </a:xfrm>
           <a:prstGeom xmlns:a="http://schemas.openxmlformats.org/drawingml/2006/main" prst="diamond">
             <a:avLst/>
@@ -2847,7 +2937,7 @@
           <a:fontRef xmlns:a="http://schemas.openxmlformats.org/drawingml/2006/main" idx="major"/>
         </p:style>
         <p:txBody>
-          <a:bodyPr xmlns:a="http://schemas.openxmlformats.org/drawingml/2006/main" lIns="0" tIns="0" rIns="0" bIns="0" anchor="ctr">
+          <a:bodyPr xmlns:a="http://schemas.openxmlformats.org/drawingml/2006/main" wrap="square" lIns="0" tIns="0" rIns="0" bIns="0" anchor="ctr">
             <a:noAutofit/>
           </a:bodyPr>
           <a:lstStyle xmlns:a="http://schemas.openxmlformats.org/drawingml/2006/main"/>
@@ -2857,7 +2947,7 @@
                 <a:spcPct val="114000"/>
               </a:lnSpc>
               <a:buNone/>
-              <a:defRPr sz="1800" b="1" i="0">
+              <a:defRPr sz="1700" b="1" i="0">
                 <a:solidFill>
                   <a:srgbClr val="FFFFFF"/>
                 </a:solidFill>
@@ -2867,7 +2957,7 @@
               </a:defRPr>
             </a:pPr>
             <a:r>
-              <a:rPr sz="1800" b="1" i="0">
+              <a:rPr sz="1700" b="1" i="0">
                 <a:solidFill>
                   <a:srgbClr val="FFFFFF"/>
                 </a:solidFill>
@@ -2883,7 +2973,7 @@
     </p:spTree>
     <p:extLst>
       <p:ext uri="{BB962C8B-B14F-4D97-AF65-F5344CB8AC3E}">
-        <p14:creationId xmlns:p14="http://schemas.microsoft.com/office/powerpoint/2010/main" val="1513753728"/>
+        <p14:creationId xmlns:p14="http://schemas.microsoft.com/office/powerpoint/2010/main" val="927580239"/>
       </p:ext>
     </p:extLst>
   </p:cSld>
@@ -3093,18 +3183,36 @@
         </a:effectStyle>
         <a:effectStyle>
           <a:effectLst>
+            <a:outerShdw blurRad="266700" dist="114300" dir="5400000">
+              <a:srgbClr val="2F5EA8">
+                <a:alpha val="22000"/>
+              </a:srgbClr>
+            </a:outerShdw>
+          </a:effectLst>
+        </a:effectStyle>
+        <a:effectStyle>
+          <a:effectLst>
+            <a:outerShdw blurRad="152400" dist="66675" dir="5400000">
+              <a:srgbClr val="2F5EA8">
+                <a:alpha val="9000"/>
+              </a:srgbClr>
+            </a:outerShdw>
+          </a:effectLst>
+        </a:effectStyle>
+        <a:effectStyle>
+          <a:effectLst>
+            <a:outerShdw blurRad="152400" dist="66675" dir="5400000">
+              <a:srgbClr val="2F5EA8">
+                <a:alpha val="10000"/>
+              </a:srgbClr>
+            </a:outerShdw>
+          </a:effectLst>
+        </a:effectStyle>
+        <a:effectStyle>
+          <a:effectLst>
             <a:outerShdw blurRad="171450" dist="76200" dir="5400000">
               <a:srgbClr val="2F5EA8">
                 <a:alpha val="16000"/>
-              </a:srgbClr>
-            </a:outerShdw>
-          </a:effectLst>
-        </a:effectStyle>
-        <a:effectStyle>
-          <a:effectLst>
-            <a:outerShdw blurRad="152400" dist="66675" dir="5400000">
-              <a:srgbClr val="2F5EA8">
-                <a:alpha val="10000"/>
               </a:srgbClr>
             </a:outerShdw>
           </a:effectLst>

</xml_diff>